<commit_message>
docs: update youtube demo link into Slide.
</commit_message>
<xml_diff>
--- a/thuan/Slide.pptx
+++ b/thuan/Slide.pptx
@@ -51905,7 +51905,7 @@
         </p:nvSpPr>
         <p:spPr>
           <a:xfrm>
-            <a:off x="457200" y="4023360"/>
+            <a:off x="457200" y="3931920"/>
             <a:ext cx="8229600" cy="274320"/>
           </a:xfrm>
           <a:prstGeom prst="rect">
@@ -51933,6 +51933,84 @@
               <a:t>Moving to Live Demo on Postman...</a:t>
             </a:r>
             <a:endParaRPr lang="en-US" sz="1200" dirty="0"/>
+          </a:p>
+        </p:txBody>
+      </p:sp>
+      <p:sp>
+        <p:nvSpPr>
+          <p:cNvPr id="2" name="Text 17">
+            <a:extLst>
+              <a:ext uri="{FF2B5EF4-FFF2-40B4-BE49-F238E27FC236}">
+                <a16:creationId xmlns:a16="http://schemas.microsoft.com/office/drawing/2014/main" id="{1E614682-DAC6-603B-E4AC-97059A736A2C}"/>
+              </a:ext>
+            </a:extLst>
+          </p:cNvPr>
+          <p:cNvSpPr/>
+          <p:nvPr/>
+        </p:nvSpPr>
+        <p:spPr>
+          <a:xfrm>
+            <a:off x="457200" y="4203382"/>
+            <a:ext cx="8229600" cy="274320"/>
+          </a:xfrm>
+          <a:prstGeom prst="rect">
+            <a:avLst/>
+          </a:prstGeom>
+          <a:noFill/>
+          <a:ln/>
+        </p:spPr>
+        <p:txBody>
+          <a:bodyPr wrap="square" rtlCol="0" anchor="ctr"/>
+          <a:lstStyle/>
+          <a:p>
+            <a:pPr marL="0" indent="0" algn="ctr">
+              <a:buNone/>
+            </a:pPr>
+            <a:r>
+              <a:rPr lang="en-US" sz="1200" i="1" dirty="0" err="1">
+                <a:solidFill>
+                  <a:srgbClr val="E8EFFC"/>
+                </a:solidFill>
+                <a:latin typeface="Calibri" pitchFamily="34" charset="0"/>
+                <a:ea typeface="Calibri" pitchFamily="34" charset="-122"/>
+                <a:cs typeface="Calibri" pitchFamily="34" charset="-120"/>
+              </a:rPr>
+              <a:t>Youtube</a:t>
+            </a:r>
+            <a:r>
+              <a:rPr lang="en-US" sz="1200" i="1" dirty="0">
+                <a:solidFill>
+                  <a:srgbClr val="E8EFFC"/>
+                </a:solidFill>
+                <a:latin typeface="Calibri" pitchFamily="34" charset="0"/>
+                <a:ea typeface="Calibri" pitchFamily="34" charset="-122"/>
+                <a:cs typeface="Calibri" pitchFamily="34" charset="-120"/>
+              </a:rPr>
+              <a:t> Link: </a:t>
+            </a:r>
+            <a:r>
+              <a:rPr lang="en-US" sz="1200" i="1" dirty="0">
+                <a:solidFill>
+                  <a:srgbClr val="E8EFFC"/>
+                </a:solidFill>
+                <a:latin typeface="Calibri" pitchFamily="34" charset="0"/>
+                <a:ea typeface="Calibri" pitchFamily="34" charset="-122"/>
+                <a:cs typeface="Calibri" pitchFamily="34" charset="-120"/>
+                <a:hlinkClick r:id="rId2"/>
+              </a:rPr>
+              <a:t>https://youtu.be/EHq4QRIPkGk?si=99hrkHmI-ct2ELI8</a:t>
+            </a:r>
+            <a:r>
+              <a:rPr lang="en-US" sz="1200" i="1" dirty="0">
+                <a:solidFill>
+                  <a:srgbClr val="E8EFFC"/>
+                </a:solidFill>
+                <a:latin typeface="Calibri" pitchFamily="34" charset="0"/>
+                <a:ea typeface="Calibri" pitchFamily="34" charset="-122"/>
+                <a:cs typeface="Calibri" pitchFamily="34" charset="-120"/>
+              </a:rPr>
+              <a:t> </a:t>
+            </a:r>
           </a:p>
         </p:txBody>
       </p:sp>

</xml_diff>